<commit_message>
refactor(nx): layer data → state
Libs <slice>/data, feat-*/data → state, tag type:state. Konventionen, eslint-matrix, generatoren (--state), eslint-rules, verify, dist-snapshot, doku/html/pptx nachgezogen.

Co-Authored-By: Claude Opus 5.5 (1M context) <noreply@anthropic.com>
</commit_message>
<xml_diff>
--- a/docs/architektur.pptx
+++ b/docs/architektur.pptx
@@ -2954,6 +2954,10 @@
             <a:prstDash val="dash"/>
           </a:ln>
         </p:spPr>
+        <p:txBody>
+          <a:bodyPr/>
+          <a:p/>
+        </p:txBody>
       </p:sp>
       <p:sp>
         <p:nvSpPr>
@@ -3168,7 +3172,7 @@
                 <a:ea typeface="Courier New" pitchFamily="34" charset="-122"/>
                 <a:cs typeface="Courier New" pitchFamily="34" charset="-120"/>
               </a:rPr>
-              <a:t>data</a:t>
+              <a:t>state</a:t>
             </a:r>
             <a:endParaRPr lang="en-US" sz="1200" dirty="0"/>
           </a:p>
@@ -3294,6 +3298,10 @@
             <a:prstDash val="dash"/>
           </a:ln>
         </p:spPr>
+        <p:txBody>
+          <a:bodyPr/>
+          <a:p/>
+        </p:txBody>
       </p:sp>
       <p:sp>
         <p:nvSpPr>
@@ -3634,6 +3642,10 @@
             <a:prstDash val="dash"/>
           </a:ln>
         </p:spPr>
+        <p:txBody>
+          <a:bodyPr/>
+          <a:p/>
+        </p:txBody>
       </p:sp>
       <p:sp>
         <p:nvSpPr>
@@ -4276,6 +4288,10 @@
             <a:prstDash val="solid"/>
           </a:ln>
         </p:spPr>
+        <p:txBody>
+          <a:bodyPr/>
+          <a:p/>
+        </p:txBody>
       </p:sp>
       <p:sp>
         <p:nvSpPr>
@@ -4381,6 +4397,10 @@
             <a:prstDash val="solid"/>
           </a:ln>
         </p:spPr>
+        <p:txBody>
+          <a:bodyPr/>
+          <a:p/>
+        </p:txBody>
       </p:sp>
       <p:sp>
         <p:nvSpPr>
@@ -4483,6 +4503,10 @@
             <a:tailEnd type="triangle"/>
           </a:ln>
         </p:spPr>
+        <p:txBody>
+          <a:bodyPr/>
+          <a:p/>
+        </p:txBody>
       </p:sp>
       <p:sp>
         <p:nvSpPr>
@@ -4510,6 +4534,10 @@
             <a:prstDash val="solid"/>
           </a:ln>
         </p:spPr>
+        <p:txBody>
+          <a:bodyPr/>
+          <a:p/>
+        </p:txBody>
       </p:sp>
       <p:sp>
         <p:nvSpPr>
@@ -4655,6 +4683,10 @@
             <a:tailEnd type="triangle"/>
           </a:ln>
         </p:spPr>
+        <p:txBody>
+          <a:bodyPr/>
+          <a:p/>
+        </p:txBody>
       </p:sp>
       <p:sp>
         <p:nvSpPr>
@@ -4682,6 +4714,10 @@
             <a:prstDash val="solid"/>
           </a:ln>
         </p:spPr>
+        <p:txBody>
+          <a:bodyPr/>
+          <a:p/>
+        </p:txBody>
       </p:sp>
       <p:sp>
         <p:nvSpPr>
@@ -4827,6 +4863,10 @@
             <a:tailEnd type="triangle"/>
           </a:ln>
         </p:spPr>
+        <p:txBody>
+          <a:bodyPr/>
+          <a:p/>
+        </p:txBody>
       </p:sp>
       <p:sp>
         <p:nvSpPr>
@@ -4854,6 +4894,10 @@
             <a:prstDash val="solid"/>
           </a:ln>
         </p:spPr>
+        <p:txBody>
+          <a:bodyPr/>
+          <a:p/>
+        </p:txBody>
       </p:sp>
       <p:sp>
         <p:nvSpPr>
@@ -4999,6 +5043,10 @@
             <a:tailEnd type="triangle"/>
           </a:ln>
         </p:spPr>
+        <p:txBody>
+          <a:bodyPr/>
+          <a:p/>
+        </p:txBody>
       </p:sp>
       <p:sp>
         <p:nvSpPr>
@@ -5026,6 +5074,10 @@
             <a:prstDash val="solid"/>
           </a:ln>
         </p:spPr>
+        <p:txBody>
+          <a:bodyPr/>
+          <a:p/>
+        </p:txBody>
       </p:sp>
       <p:sp>
         <p:nvSpPr>
@@ -5171,6 +5223,10 @@
             <a:tailEnd type="triangle"/>
           </a:ln>
         </p:spPr>
+        <p:txBody>
+          <a:bodyPr/>
+          <a:p/>
+        </p:txBody>
       </p:sp>
       <p:sp>
         <p:nvSpPr>
@@ -5198,6 +5254,10 @@
             <a:prstDash val="solid"/>
           </a:ln>
         </p:spPr>
+        <p:txBody>
+          <a:bodyPr/>
+          <a:p/>
+        </p:txBody>
       </p:sp>
       <p:sp>
         <p:nvSpPr>
@@ -5314,6 +5374,10 @@
             <a:tailEnd type="triangle"/>
           </a:ln>
         </p:spPr>
+        <p:txBody>
+          <a:bodyPr/>
+          <a:p/>
+        </p:txBody>
       </p:sp>
       <p:sp>
         <p:nvSpPr>
@@ -5341,6 +5405,10 @@
             <a:prstDash val="solid"/>
           </a:ln>
         </p:spPr>
+        <p:txBody>
+          <a:bodyPr/>
+          <a:p/>
+        </p:txBody>
       </p:sp>
       <p:sp>
         <p:nvSpPr>
@@ -5414,7 +5482,7 @@
                 <a:ea typeface="Arial" pitchFamily="34" charset="-122"/>
                 <a:cs typeface="Arial" pitchFamily="34" charset="-120"/>
               </a:rPr>
-              <a:t>data, feature, …</a:t>
+              <a:t>state, feature, …</a:t>
             </a:r>
             <a:endParaRPr lang="en-US" sz="1050" dirty="0"/>
           </a:p>
@@ -5443,6 +5511,10 @@
             <a:tailEnd type="triangle"/>
           </a:ln>
         </p:spPr>
+        <p:txBody>
+          <a:bodyPr/>
+          <a:p/>
+        </p:txBody>
       </p:sp>
       <p:sp>
         <p:nvSpPr>
@@ -5470,6 +5542,10 @@
             <a:prstDash val="solid"/>
           </a:ln>
         </p:spPr>
+        <p:txBody>
+          <a:bodyPr/>
+          <a:p/>
+        </p:txBody>
       </p:sp>
       <p:sp>
         <p:nvSpPr>
@@ -5953,6 +6029,10 @@
             <a:prstDash val="solid"/>
           </a:ln>
         </p:spPr>
+        <p:txBody>
+          <a:bodyPr/>
+          <a:p/>
+        </p:txBody>
       </p:sp>
       <p:sp>
         <p:nvSpPr>
@@ -6587,6 +6667,10 @@
             <a:prstDash val="solid"/>
           </a:ln>
         </p:spPr>
+        <p:txBody>
+          <a:bodyPr/>
+          <a:p/>
+        </p:txBody>
       </p:sp>
       <p:sp>
         <p:nvSpPr>
@@ -6703,7 +6787,7 @@
                 <a:ea typeface="Courier New" pitchFamily="34" charset="-122"/>
                 <a:cs typeface="Courier New" pitchFamily="34" charset="-120"/>
               </a:rPr>
-              <a:t>libs/checkin/data/src/checkin.store.ts</a:t>
+              <a:t>libs/checkin/state/src/checkin.store.ts</a:t>
             </a:r>
             <a:endParaRPr lang="en-US" sz="1000" dirty="0"/>
           </a:p>
@@ -6735,6 +6819,10 @@
             <a:prstDash val="solid"/>
           </a:ln>
         </p:spPr>
+        <p:txBody>
+          <a:bodyPr/>
+          <a:p/>
+        </p:txBody>
       </p:sp>
       <p:sp>
         <p:nvSpPr>
@@ -6840,6 +6928,10 @@
             <a:prstDash val="solid"/>
           </a:ln>
         </p:spPr>
+        <p:txBody>
+          <a:bodyPr/>
+          <a:p/>
+        </p:txBody>
       </p:sp>
       <p:sp>
         <p:nvSpPr>
@@ -6956,7 +7048,7 @@
                 <a:ea typeface="Courier New" pitchFamily="34" charset="-122"/>
                 <a:cs typeface="Courier New" pitchFamily="34" charset="-120"/>
               </a:rPr>
-              <a:t>libs/checkin/data/src/checkin.store.ts</a:t>
+              <a:t>libs/checkin/state/src/checkin.store.ts</a:t>
             </a:r>
             <a:endParaRPr lang="en-US" sz="1000" dirty="0"/>
           </a:p>
@@ -6988,6 +7080,10 @@
             <a:prstDash val="solid"/>
           </a:ln>
         </p:spPr>
+        <p:txBody>
+          <a:bodyPr/>
+          <a:p/>
+        </p:txBody>
       </p:sp>
       <p:sp>
         <p:nvSpPr>
@@ -7022,7 +7118,7 @@
                 <a:ea typeface="Courier New" pitchFamily="34" charset="-122"/>
                 <a:cs typeface="Courier New" pitchFamily="34" charset="-120"/>
               </a:rPr>
-              <a:t>import { BookingStore } from '@blueprint/booking/data';</a:t>
+              <a:t>import { BookingStore } from '@blueprint/booking/state';</a:t>
             </a:r>
             <a:endParaRPr lang="en-US" sz="1200" dirty="0"/>
           </a:p>
@@ -7132,6 +7228,10 @@
             <a:prstDash val="solid"/>
           </a:ln>
         </p:spPr>
+        <p:txBody>
+          <a:bodyPr/>
+          <a:p/>
+        </p:txBody>
       </p:sp>
       <p:sp>
         <p:nvSpPr>
@@ -7248,7 +7348,7 @@
                 <a:ea typeface="Courier New" pitchFamily="34" charset="-122"/>
                 <a:cs typeface="Courier New" pitchFamily="34" charset="-120"/>
               </a:rPr>
-              <a:t>libs/booking/data/src/booking.store.ts</a:t>
+              <a:t>libs/booking/state/src/booking.store.ts</a:t>
             </a:r>
             <a:endParaRPr lang="en-US" sz="1000" dirty="0"/>
           </a:p>
@@ -7280,6 +7380,10 @@
             <a:prstDash val="solid"/>
           </a:ln>
         </p:spPr>
+        <p:txBody>
+          <a:bodyPr/>
+          <a:p/>
+        </p:txBody>
       </p:sp>
       <p:sp>
         <p:nvSpPr>
@@ -7353,7 +7457,7 @@
                 <a:ea typeface="Arial" pitchFamily="34" charset="-122"/>
                 <a:cs typeface="Arial" pitchFamily="34" charset="-120"/>
               </a:rPr>
-              <a:t>data → api ist laut Matrix erlaubt.</a:t>
+              <a:t>state → api ist laut Matrix erlaubt.</a:t>
             </a:r>
             <a:endParaRPr lang="en-US" sz="1200" dirty="0"/>
           </a:p>
@@ -7385,6 +7489,10 @@
             <a:prstDash val="solid"/>
           </a:ln>
         </p:spPr>
+        <p:txBody>
+          <a:bodyPr/>
+          <a:p/>
+        </p:txBody>
       </p:sp>
       <p:sp>
         <p:nvSpPr>
@@ -7533,6 +7641,10 @@
             <a:prstDash val="solid"/>
           </a:ln>
         </p:spPr>
+        <p:txBody>
+          <a:bodyPr/>
+          <a:p/>
+        </p:txBody>
       </p:sp>
       <p:sp>
         <p:nvSpPr>
@@ -7567,7 +7679,7 @@
                 <a:ea typeface="Courier New" pitchFamily="34" charset="-122"/>
                 <a:cs typeface="Courier New" pitchFamily="34" charset="-120"/>
               </a:rPr>
-              <a:t>import { BookingStore } from '@blueprint/booking/data';</a:t>
+              <a:t>import { BookingStore } from '@blueprint/booking/state';</a:t>
             </a:r>
             <a:endParaRPr lang="en-US" sz="1200" dirty="0"/>
           </a:p>
@@ -7826,6 +7938,10 @@
             <a:prstDash val="solid"/>
           </a:ln>
         </p:spPr>
+        <p:txBody>
+          <a:bodyPr/>
+          <a:p/>
+        </p:txBody>
       </p:sp>
       <p:sp>
         <p:nvSpPr>
@@ -7974,6 +8090,10 @@
             <a:prstDash val="solid"/>
           </a:ln>
         </p:spPr>
+        <p:txBody>
+          <a:bodyPr/>
+          <a:p/>
+        </p:txBody>
       </p:sp>
       <p:sp>
         <p:nvSpPr>
@@ -8079,6 +8199,10 @@
             <a:prstDash val="solid"/>
           </a:ln>
         </p:spPr>
+        <p:txBody>
+          <a:bodyPr/>
+          <a:p/>
+        </p:txBody>
       </p:sp>
       <p:sp>
         <p:nvSpPr>
@@ -8227,6 +8351,10 @@
             <a:prstDash val="solid"/>
           </a:ln>
         </p:spPr>
+        <p:txBody>
+          <a:bodyPr/>
+          <a:p/>
+        </p:txBody>
       </p:sp>
       <p:sp>
         <p:nvSpPr>
@@ -8261,7 +8389,7 @@
                 <a:ea typeface="Courier New" pitchFamily="34" charset="-122"/>
                 <a:cs typeface="Courier New" pitchFamily="34" charset="-120"/>
               </a:rPr>
-              <a:t>import { CheckinDeskStore } from '@blueprint/checkin/feat-checkin/data';</a:t>
+              <a:t>import { CheckinDeskStore } from '@blueprint/checkin/feat-checkin/state';</a:t>
             </a:r>
             <a:endParaRPr lang="en-US" sz="1200" dirty="0"/>
           </a:p>
@@ -8371,6 +8499,10 @@
             <a:prstDash val="solid"/>
           </a:ln>
         </p:spPr>
+        <p:txBody>
+          <a:bodyPr/>
+          <a:p/>
+        </p:txBody>
       </p:sp>
       <p:sp>
         <p:nvSpPr>
@@ -8519,6 +8651,10 @@
             <a:prstDash val="solid"/>
           </a:ln>
         </p:spPr>
+        <p:txBody>
+          <a:bodyPr/>
+          <a:p/>
+        </p:txBody>
       </p:sp>
       <p:sp>
         <p:nvSpPr>
@@ -8641,6 +8777,10 @@
             <a:prstDash val="solid"/>
           </a:ln>
         </p:spPr>
+        <p:txBody>
+          <a:bodyPr/>
+          <a:p/>
+        </p:txBody>
       </p:sp>
       <p:sp>
         <p:nvSpPr>
@@ -8789,6 +8929,10 @@
             <a:prstDash val="solid"/>
           </a:ln>
         </p:spPr>
+        <p:txBody>
+          <a:bodyPr/>
+          <a:p/>
+        </p:txBody>
       </p:sp>
       <p:sp>
         <p:nvSpPr>
@@ -9082,6 +9226,10 @@
             <a:prstDash val="solid"/>
           </a:ln>
         </p:spPr>
+        <p:txBody>
+          <a:bodyPr/>
+          <a:p/>
+        </p:txBody>
       </p:sp>
       <p:sp>
         <p:nvSpPr>
@@ -9198,7 +9346,7 @@
                 <a:ea typeface="Courier New" pitchFamily="34" charset="-122"/>
                 <a:cs typeface="Courier New" pitchFamily="34" charset="-120"/>
               </a:rPr>
-              <a:t>libs/booking/data/src/booking.store.ts</a:t>
+              <a:t>libs/booking/state/src/booking.store.ts</a:t>
             </a:r>
             <a:endParaRPr lang="en-US" sz="1000" dirty="0"/>
           </a:p>
@@ -9230,6 +9378,10 @@
             <a:prstDash val="solid"/>
           </a:ln>
         </p:spPr>
+        <p:txBody>
+          <a:bodyPr/>
+          <a:p/>
+        </p:txBody>
       </p:sp>
       <p:sp>
         <p:nvSpPr>
@@ -9281,7 +9433,7 @@
                 <a:ea typeface="Courier New" pitchFamily="34" charset="-122"/>
                 <a:cs typeface="Courier New" pitchFamily="34" charset="-120"/>
               </a:rPr>
-              <a:t>  from '@blueprint/checkin/data/src/internal/checkin.mapper';</a:t>
+              <a:t>  from '@blueprint/checkin/state/src/internal/checkin.mapper';</a:t>
             </a:r>
             <a:endParaRPr lang="en-US" sz="1200" dirty="0"/>
           </a:p>
@@ -9320,7 +9472,7 @@
                 <a:ea typeface="Courier New" pitchFamily="34" charset="-122"/>
                 <a:cs typeface="Courier New" pitchFamily="34" charset="-120"/>
               </a:rPr>
-              <a:t>Deep import into @blueprint/checkin/data — only its public API (index.ts) is importable.  no-restricted-imports</a:t>
+              <a:t>Deep import into @blueprint/checkin/state — only its public API (index.ts) is importable.  no-restricted-imports</a:t>
             </a:r>
             <a:endParaRPr lang="en-US" sz="1000" dirty="0"/>
           </a:p>
@@ -9391,6 +9543,10 @@
             <a:prstDash val="solid"/>
           </a:ln>
         </p:spPr>
+        <p:txBody>
+          <a:bodyPr/>
+          <a:p/>
+        </p:txBody>
       </p:sp>
       <p:sp>
         <p:nvSpPr>
@@ -9507,7 +9663,7 @@
                 <a:ea typeface="Courier New" pitchFamily="34" charset="-122"/>
                 <a:cs typeface="Courier New" pitchFamily="34" charset="-120"/>
               </a:rPr>
-              <a:t>libs/booking/data/src/booking.store.ts</a:t>
+              <a:t>libs/booking/state/src/booking.store.ts</a:t>
             </a:r>
             <a:endParaRPr lang="en-US" sz="1000" dirty="0"/>
           </a:p>
@@ -9539,6 +9695,10 @@
             <a:prstDash val="solid"/>
           </a:ln>
         </p:spPr>
+        <p:txBody>
+          <a:bodyPr/>
+          <a:p/>
+        </p:txBody>
       </p:sp>
       <p:sp>
         <p:nvSpPr>
@@ -9612,7 +9772,7 @@
                 <a:ea typeface="Courier New" pitchFamily="34" charset="-122"/>
                 <a:cs typeface="Courier New" pitchFamily="34" charset="-120"/>
               </a:rPr>
-              <a:t>A project tagged with "type:data" is not allowed to import "@angular/common/http"</a:t>
+              <a:t>A project tagged with "type:state" is not allowed to import "@angular/common/http"</a:t>
             </a:r>
             <a:endParaRPr lang="en-US" sz="1000" dirty="0"/>
           </a:p>
@@ -9683,6 +9843,10 @@
             <a:prstDash val="solid"/>
           </a:ln>
         </p:spPr>
+        <p:txBody>
+          <a:bodyPr/>
+          <a:p/>
+        </p:txBody>
       </p:sp>
       <p:sp>
         <p:nvSpPr>
@@ -9831,6 +9995,10 @@
             <a:prstDash val="solid"/>
           </a:ln>
         </p:spPr>
+        <p:txBody>
+          <a:bodyPr/>
+          <a:p/>
+        </p:txBody>
       </p:sp>
       <p:sp>
         <p:nvSpPr>
@@ -9936,6 +10104,10 @@
             <a:prstDash val="solid"/>
           </a:ln>
         </p:spPr>
+        <p:txBody>
+          <a:bodyPr/>
+          <a:p/>
+        </p:txBody>
       </p:sp>
       <p:sp>
         <p:nvSpPr>
@@ -10084,6 +10256,10 @@
             <a:prstDash val="solid"/>
           </a:ln>
         </p:spPr>
+        <p:txBody>
+          <a:bodyPr/>
+          <a:p/>
+        </p:txBody>
       </p:sp>
       <p:sp>
         <p:nvSpPr>
@@ -10377,6 +10553,10 @@
             <a:prstDash val="solid"/>
           </a:ln>
         </p:spPr>
+        <p:txBody>
+          <a:bodyPr/>
+          <a:p/>
+        </p:txBody>
       </p:sp>
       <p:sp>
         <p:nvSpPr>
@@ -10493,7 +10673,7 @@
                 <a:ea typeface="Courier New" pitchFamily="34" charset="-122"/>
                 <a:cs typeface="Courier New" pitchFamily="34" charset="-120"/>
               </a:rPr>
-              <a:t>libs/booking/data/src/booking.store.spec.ts</a:t>
+              <a:t>libs/booking/state/src/booking.store.spec.ts</a:t>
             </a:r>
             <a:endParaRPr lang="en-US" sz="1000" dirty="0"/>
           </a:p>
@@ -10525,6 +10705,10 @@
             <a:prstDash val="solid"/>
           </a:ln>
         </p:spPr>
+        <p:txBody>
+          <a:bodyPr/>
+          <a:p/>
+        </p:txBody>
       </p:sp>
       <p:sp>
         <p:nvSpPr>
@@ -10647,6 +10831,10 @@
             <a:prstDash val="solid"/>
           </a:ln>
         </p:spPr>
+        <p:txBody>
+          <a:bodyPr/>
+          <a:p/>
+        </p:txBody>
       </p:sp>
       <p:sp>
         <p:nvSpPr>
@@ -10763,7 +10951,7 @@
                 <a:ea typeface="Courier New" pitchFamily="34" charset="-122"/>
                 <a:cs typeface="Courier New" pitchFamily="34" charset="-120"/>
               </a:rPr>
-              <a:t>libs/booking/data/src/booking.store.ts</a:t>
+              <a:t>libs/booking/state/src/booking.store.ts</a:t>
             </a:r>
             <a:endParaRPr lang="en-US" sz="1000" dirty="0"/>
           </a:p>
@@ -10795,6 +10983,10 @@
             <a:prstDash val="solid"/>
           </a:ln>
         </p:spPr>
+        <p:txBody>
+          <a:bodyPr/>
+          <a:p/>
+        </p:txBody>
       </p:sp>
       <p:sp>
         <p:nvSpPr>
@@ -10868,7 +11060,7 @@
                 <a:ea typeface="Courier New" pitchFamily="34" charset="-122"/>
                 <a:cs typeface="Courier New" pitchFamily="34" charset="-120"/>
               </a:rPr>
-              <a:t>A project tagged with "type:data" is not allowed to import "msw"</a:t>
+              <a:t>A project tagged with "type:state" is not allowed to import "msw"</a:t>
             </a:r>
             <a:endParaRPr lang="en-US" sz="1000" dirty="0"/>
           </a:p>
@@ -10939,6 +11131,10 @@
             <a:prstDash val="solid"/>
           </a:ln>
         </p:spPr>
+        <p:txBody>
+          <a:bodyPr/>
+          <a:p/>
+        </p:txBody>
       </p:sp>
       <p:sp>
         <p:nvSpPr>
@@ -11087,6 +11283,10 @@
             <a:prstDash val="solid"/>
           </a:ln>
         </p:spPr>
+        <p:txBody>
+          <a:bodyPr/>
+          <a:p/>
+        </p:txBody>
       </p:sp>
       <p:sp>
         <p:nvSpPr>
@@ -11209,6 +11409,10 @@
             <a:prstDash val="solid"/>
           </a:ln>
         </p:spPr>
+        <p:txBody>
+          <a:bodyPr/>
+          <a:p/>
+        </p:txBody>
       </p:sp>
       <p:sp>
         <p:nvSpPr>
@@ -11325,7 +11529,7 @@
                 <a:ea typeface="Courier New" pitchFamily="34" charset="-122"/>
                 <a:cs typeface="Courier New" pitchFamily="34" charset="-120"/>
               </a:rPr>
-              <a:t>libs/checkin/data/src/checkin.store.ts</a:t>
+              <a:t>libs/checkin/state/src/checkin.store.ts</a:t>
             </a:r>
             <a:endParaRPr lang="en-US" sz="1000" dirty="0"/>
           </a:p>
@@ -11357,6 +11561,10 @@
             <a:prstDash val="solid"/>
           </a:ln>
         </p:spPr>
+        <p:txBody>
+          <a:bodyPr/>
+          <a:p/>
+        </p:txBody>
       </p:sp>
       <p:sp>
         <p:nvSpPr>
@@ -12386,7 +12594,7 @@
                           <a:ea typeface="Courier New" pitchFamily="34" charset="-122"/>
                           <a:cs typeface="Courier New" pitchFamily="34" charset="-120"/>
                         </a:rPr>
-                        <a:t>data/…/booking.store.ts</a:t>
+                        <a:t>state/…/booking.store.ts</a:t>
                       </a:r>
                       <a:endParaRPr lang="en-US" sz="1200" dirty="0"/>
                     </a:p>
@@ -14817,6 +15025,10 @@
             </a:outerShdw>
           </a:effectLst>
         </p:spPr>
+        <p:txBody>
+          <a:bodyPr/>
+          <a:p/>
+        </p:txBody>
       </p:sp>
       <p:sp>
         <p:nvSpPr>
@@ -15264,6 +15476,10 @@
             </a:outerShdw>
           </a:effectLst>
         </p:spPr>
+        <p:txBody>
+          <a:bodyPr/>
+          <a:p/>
+        </p:txBody>
       </p:sp>
       <p:sp>
         <p:nvSpPr>
@@ -15501,6 +15717,10 @@
             </a:outerShdw>
           </a:effectLst>
         </p:spPr>
+        <p:txBody>
+          <a:bodyPr/>
+          <a:p/>
+        </p:txBody>
       </p:sp>
       <p:sp>
         <p:nvSpPr>
@@ -15780,6 +16000,10 @@
             </a:outerShdw>
           </a:effectLst>
         </p:spPr>
+        <p:txBody>
+          <a:bodyPr/>
+          <a:p/>
+        </p:txBody>
       </p:sp>
       <p:sp>
         <p:nvSpPr>
@@ -16045,6 +16269,10 @@
             </a:outerShdw>
           </a:effectLst>
         </p:spPr>
+        <p:txBody>
+          <a:bodyPr/>
+          <a:p/>
+        </p:txBody>
       </p:sp>
       <p:sp>
         <p:nvSpPr>
@@ -16513,6 +16741,10 @@
             <a:prstDash val="solid"/>
           </a:ln>
         </p:spPr>
+        <p:txBody>
+          <a:bodyPr/>
+          <a:p/>
+        </p:txBody>
       </p:sp>
       <p:sp>
         <p:nvSpPr>
@@ -16686,6 +16918,10 @@
             <a:prstDash val="solid"/>
           </a:ln>
         </p:spPr>
+        <p:txBody>
+          <a:bodyPr/>
+          <a:p/>
+        </p:txBody>
       </p:sp>
       <p:sp>
         <p:nvSpPr>
@@ -16842,6 +17078,10 @@
             <a:prstDash val="solid"/>
           </a:ln>
         </p:spPr>
+        <p:txBody>
+          <a:bodyPr/>
+          <a:p/>
+        </p:txBody>
       </p:sp>
       <p:sp>
         <p:nvSpPr>
@@ -16998,6 +17238,10 @@
             <a:prstDash val="solid"/>
           </a:ln>
         </p:spPr>
+        <p:txBody>
+          <a:bodyPr/>
+          <a:p/>
+        </p:txBody>
       </p:sp>
       <p:sp>
         <p:nvSpPr>
@@ -17083,7 +17327,7 @@
                 <a:ea typeface="Courier New" pitchFamily="34" charset="-122"/>
                 <a:cs typeface="Courier New" pitchFamily="34" charset="-120"/>
               </a:rPr>
-              <a:t>pnpm exec nx lint checkin-data</a:t>
+              <a:t>pnpm exec nx lint checkin-state</a:t>
             </a:r>
             <a:endParaRPr lang="en-US" sz="1300" dirty="0"/>
           </a:p>
@@ -17288,6 +17532,10 @@
             </a:outerShdw>
           </a:effectLst>
         </p:spPr>
+        <p:txBody>
+          <a:bodyPr/>
+          <a:p/>
+        </p:txBody>
       </p:sp>
       <p:sp>
         <p:nvSpPr>
@@ -17525,6 +17773,10 @@
             </a:outerShdw>
           </a:effectLst>
         </p:spPr>
+        <p:txBody>
+          <a:bodyPr/>
+          <a:p/>
+        </p:txBody>
       </p:sp>
       <p:sp>
         <p:nvSpPr>
@@ -17678,6 +17930,10 @@
             </a:outerShdw>
           </a:effectLst>
         </p:spPr>
+        <p:txBody>
+          <a:bodyPr/>
+          <a:p/>
+        </p:txBody>
       </p:sp>
       <p:sp>
         <p:nvSpPr>
@@ -17936,6 +18192,10 @@
             <a:prstDash val="solid"/>
           </a:ln>
         </p:spPr>
+        <p:txBody>
+          <a:bodyPr/>
+          <a:p/>
+        </p:txBody>
       </p:sp>
       <p:sp>
         <p:nvSpPr>
@@ -18017,7 +18277,7 @@
                 <a:ea typeface="Courier New" pitchFamily="34" charset="-122"/>
                 <a:cs typeface="Courier New" pitchFamily="34" charset="-120"/>
               </a:rPr>
-              <a:t>libs/booking/feat-check-booking/data</a:t>
+              <a:t>libs/booking/feat-check-booking/state</a:t>
             </a:r>
             <a:endParaRPr lang="en-US" sz="1300" dirty="0"/>
           </a:p>
@@ -18046,6 +18306,10 @@
             <a:tailEnd type="triangle"/>
           </a:ln>
         </p:spPr>
+        <p:txBody>
+          <a:bodyPr/>
+          <a:p/>
+        </p:txBody>
       </p:sp>
       <p:sp>
         <p:nvSpPr>
@@ -18109,6 +18373,10 @@
             <a:tailEnd type="triangle"/>
           </a:ln>
         </p:spPr>
+        <p:txBody>
+          <a:bodyPr/>
+          <a:p/>
+        </p:txBody>
       </p:sp>
       <p:sp>
         <p:nvSpPr>
@@ -18172,6 +18440,10 @@
             <a:tailEnd type="triangle"/>
           </a:ln>
         </p:spPr>
+        <p:txBody>
+          <a:bodyPr/>
+          <a:p/>
+        </p:txBody>
       </p:sp>
       <p:sp>
         <p:nvSpPr>
@@ -18245,7 +18517,7 @@
                 <a:ea typeface="Courier New" pitchFamily="34" charset="-122"/>
                 <a:cs typeface="Courier New" pitchFamily="34" charset="-120"/>
               </a:rPr>
-              <a:t>booking-feat-check-booking-data</a:t>
+              <a:t>booking-feat-check-booking-state</a:t>
             </a:r>
             <a:endParaRPr lang="en-US" sz="1300" dirty="0"/>
           </a:p>
@@ -18284,7 +18556,7 @@
                 <a:ea typeface="Courier New" pitchFamily="34" charset="-122"/>
                 <a:cs typeface="Courier New" pitchFamily="34" charset="-120"/>
               </a:rPr>
-              <a:t>@blueprint/booking/feat-check-booking/data</a:t>
+              <a:t>@blueprint/booking/feat-check-booking/state</a:t>
             </a:r>
             <a:endParaRPr lang="en-US" sz="1300" dirty="0"/>
           </a:p>
@@ -18451,7 +18723,7 @@
                 <a:ea typeface="Courier New" pitchFamily="34" charset="-122"/>
                 <a:cs typeface="Courier New" pitchFamily="34" charset="-120"/>
               </a:rPr>
-              <a:t>type:data</a:t>
+              <a:t>type:state</a:t>
             </a:r>
             <a:endParaRPr lang="en-US" sz="1100" dirty="0"/>
           </a:p>
@@ -18682,6 +18954,10 @@
             </a:outerShdw>
           </a:effectLst>
         </p:spPr>
+        <p:txBody>
+          <a:bodyPr/>
+          <a:p/>
+        </p:txBody>
       </p:sp>
       <p:sp>
         <p:nvSpPr>
@@ -18826,6 +19102,10 @@
             <a:prstDash val="dash"/>
           </a:ln>
         </p:spPr>
+        <p:txBody>
+          <a:bodyPr/>
+          <a:p/>
+        </p:txBody>
       </p:sp>
       <p:sp>
         <p:nvSpPr>
@@ -18927,6 +19207,10 @@
             <a:prstDash val="solid"/>
           </a:ln>
         </p:spPr>
+        <p:txBody>
+          <a:bodyPr/>
+          <a:p/>
+        </p:txBody>
       </p:sp>
       <p:sp>
         <p:nvSpPr>
@@ -19118,6 +19402,10 @@
             <a:prstDash val="solid"/>
           </a:ln>
         </p:spPr>
+        <p:txBody>
+          <a:bodyPr/>
+          <a:p/>
+        </p:txBody>
       </p:sp>
       <p:sp>
         <p:nvSpPr>
@@ -19152,7 +19440,7 @@
                 <a:ea typeface="Courier New" pitchFamily="34" charset="-122"/>
                 <a:cs typeface="Courier New" pitchFamily="34" charset="-120"/>
               </a:rPr>
-              <a:t>data/  ui/</a:t>
+              <a:t>state/  ui/</a:t>
             </a:r>
             <a:endParaRPr lang="en-US" sz="1200" dirty="0"/>
           </a:p>
@@ -19238,7 +19526,7 @@
                 <a:ea typeface="Courier New" pitchFamily="34" charset="-122"/>
                 <a:cs typeface="Courier New" pitchFamily="34" charset="-120"/>
               </a:rPr>
-              <a:t>type:data · type:ui</a:t>
+              <a:t>type:state · type:ui</a:t>
             </a:r>
             <a:endParaRPr lang="en-US" sz="1000" dirty="0"/>
           </a:p>
@@ -19309,6 +19597,10 @@
             <a:prstDash val="solid"/>
           </a:ln>
         </p:spPr>
+        <p:txBody>
+          <a:bodyPr/>
+          <a:p/>
+        </p:txBody>
       </p:sp>
       <p:sp>
         <p:nvSpPr>
@@ -19539,6 +19831,10 @@
             <a:prstDash val="solid"/>
           </a:ln>
         </p:spPr>
+        <p:txBody>
+          <a:bodyPr/>
+          <a:p/>
+        </p:txBody>
       </p:sp>
       <p:sp>
         <p:nvSpPr>
@@ -19769,6 +20065,10 @@
             <a:prstDash val="solid"/>
           </a:ln>
         </p:spPr>
+        <p:txBody>
+          <a:bodyPr/>
+          <a:p/>
+        </p:txBody>
       </p:sp>
       <p:sp>
         <p:nvSpPr>
@@ -19960,6 +20260,10 @@
             <a:prstDash val="solid"/>
           </a:ln>
         </p:spPr>
+        <p:txBody>
+          <a:bodyPr/>
+          <a:p/>
+        </p:txBody>
       </p:sp>
       <p:sp>
         <p:nvSpPr>
@@ -20151,6 +20455,10 @@
             <a:prstDash val="solid"/>
           </a:ln>
         </p:spPr>
+        <p:txBody>
+          <a:bodyPr/>
+          <a:p/>
+        </p:txBody>
       </p:sp>
       <p:sp>
         <p:nvSpPr>
@@ -20185,7 +20493,7 @@
                 <a:ea typeface="Courier New" pitchFamily="34" charset="-122"/>
                 <a:cs typeface="Courier New" pitchFamily="34" charset="-120"/>
               </a:rPr>
-              <a:t>feat-check-booking/data/ ui/</a:t>
+              <a:t>feat-check-booking/state/ ui/</a:t>
             </a:r>
             <a:endParaRPr lang="en-US" sz="1200" dirty="0"/>
           </a:p>
@@ -20228,7 +20536,7 @@
                 <a:ea typeface="Courier New" pitchFamily="34" charset="-122"/>
                 <a:cs typeface="Courier New" pitchFamily="34" charset="-120"/>
               </a:rPr>
-              <a:t>type:data · type:ui</a:t>
+              <a:t>type:state · type:ui</a:t>
             </a:r>
             <a:endParaRPr lang="en-US" sz="1000" dirty="0"/>
           </a:p>
@@ -20299,6 +20607,10 @@
             <a:prstDash val="solid"/>
           </a:ln>
         </p:spPr>
+        <p:txBody>
+          <a:bodyPr/>
+          <a:p/>
+        </p:txBody>
       </p:sp>
       <p:sp>
         <p:nvSpPr>
@@ -20486,6 +20798,10 @@
             <a:prstDash val="solid"/>
           </a:ln>
         </p:spPr>
+        <p:txBody>
+          <a:bodyPr/>
+          <a:p/>
+        </p:txBody>
       </p:sp>
       <p:sp>
         <p:nvSpPr>
@@ -20673,6 +20989,10 @@
             <a:prstDash val="dash"/>
           </a:ln>
         </p:spPr>
+        <p:txBody>
+          <a:bodyPr/>
+          <a:p/>
+        </p:txBody>
       </p:sp>
       <p:sp>
         <p:nvSpPr>
@@ -20938,6 +21258,10 @@
             <a:prstDash val="dash"/>
           </a:ln>
         </p:spPr>
+        <p:txBody>
+          <a:bodyPr/>
+          <a:p/>
+        </p:txBody>
       </p:sp>
       <p:sp>
         <p:nvSpPr>
@@ -21453,6 +21777,10 @@
             <a:prstDash val="dash"/>
           </a:ln>
         </p:spPr>
+        <p:txBody>
+          <a:bodyPr/>
+          <a:p/>
+        </p:txBody>
       </p:sp>
       <p:sp>
         <p:nvSpPr>
@@ -21597,6 +21925,10 @@
             <a:prstDash val="solid"/>
           </a:ln>
         </p:spPr>
+        <p:txBody>
+          <a:bodyPr/>
+          <a:p/>
+        </p:txBody>
       </p:sp>
       <p:sp>
         <p:nvSpPr>
@@ -21812,6 +22144,10 @@
             <a:prstDash val="solid"/>
           </a:ln>
         </p:spPr>
+        <p:txBody>
+          <a:bodyPr/>
+          <a:p/>
+        </p:txBody>
       </p:sp>
       <p:sp>
         <p:nvSpPr>
@@ -22160,6 +22496,10 @@
             <a:prstDash val="solid"/>
           </a:ln>
         </p:spPr>
+        <p:txBody>
+          <a:bodyPr/>
+          <a:p/>
+        </p:txBody>
       </p:sp>
       <p:sp>
         <p:nvSpPr>
@@ -22409,7 +22749,7 @@
                 <a:ea typeface="Courier New" pitchFamily="34" charset="-122"/>
                 <a:cs typeface="Courier New" pitchFamily="34" charset="-120"/>
               </a:rPr>
-              <a:t>data</a:t>
+              <a:t>state</a:t>
             </a:r>
             <a:endParaRPr lang="en-US" sz="1000" dirty="0"/>
           </a:p>
@@ -22695,6 +23035,10 @@
             <a:prstDash val="solid"/>
           </a:ln>
         </p:spPr>
+        <p:txBody>
+          <a:bodyPr/>
+          <a:p/>
+        </p:txBody>
       </p:sp>
       <p:sp>
         <p:nvSpPr>
@@ -23071,6 +23415,10 @@
             <a:prstDash val="solid"/>
           </a:ln>
         </p:spPr>
+        <p:txBody>
+          <a:bodyPr/>
+          <a:p/>
+        </p:txBody>
       </p:sp>
       <p:sp>
         <p:nvSpPr>
@@ -23524,6 +23872,10 @@
             <a:prstDash val="solid"/>
           </a:ln>
         </p:spPr>
+        <p:txBody>
+          <a:bodyPr/>
+          <a:p/>
+        </p:txBody>
       </p:sp>
       <p:sp>
         <p:nvSpPr>
@@ -23805,6 +24157,10 @@
             <a:prstDash val="solid"/>
           </a:ln>
         </p:spPr>
+        <p:txBody>
+          <a:bodyPr/>
+          <a:p/>
+        </p:txBody>
       </p:sp>
       <p:sp>
         <p:nvSpPr>
@@ -24097,7 +24453,7 @@
                 <a:ea typeface="Courier New" pitchFamily="34" charset="-122"/>
                 <a:cs typeface="Courier New" pitchFamily="34" charset="-120"/>
               </a:rPr>
-              <a:t>type:data</a:t>
+              <a:t>type:state</a:t>
             </a:r>
             <a:endParaRPr lang="en-US" sz="1000" dirty="0"/>
           </a:p>
@@ -24258,6 +24614,10 @@
             <a:prstDash val="solid"/>
           </a:ln>
         </p:spPr>
+        <p:txBody>
+          <a:bodyPr/>
+          <a:p/>
+        </p:txBody>
       </p:sp>
       <p:sp>
         <p:nvSpPr>
@@ -24691,6 +25051,10 @@
             </a:outerShdw>
           </a:effectLst>
         </p:spPr>
+        <p:txBody>
+          <a:bodyPr/>
+          <a:p/>
+        </p:txBody>
       </p:sp>
       <p:sp>
         <p:nvSpPr>
@@ -24920,7 +25284,7 @@
                 <a:ea typeface="Courier New" pitchFamily="34" charset="-122"/>
                 <a:cs typeface="Courier New" pitchFamily="34" charset="-120"/>
               </a:rPr>
-              <a:t>data</a:t>
+              <a:t>state</a:t>
             </a:r>
             <a:endParaRPr lang="en-US" sz="1100" dirty="0"/>
           </a:p>
@@ -26608,7 +26972,7 @@
                 <a:ea typeface="Courier New" pitchFamily="34" charset="-122"/>
                 <a:cs typeface="Courier New" pitchFamily="34" charset="-120"/>
               </a:rPr>
-              <a:t>data</a:t>
+              <a:t>state</a:t>
             </a:r>
             <a:endParaRPr lang="en-US" sz="1200" dirty="0"/>
           </a:p>
@@ -28133,6 +28497,10 @@
             <a:prstDash val="solid"/>
           </a:ln>
         </p:spPr>
+        <p:txBody>
+          <a:bodyPr/>
+          <a:p/>
+        </p:txBody>
       </p:sp>
       <p:sp>
         <p:nvSpPr>
@@ -28459,6 +28827,10 @@
             <a:prstDash val="solid"/>
           </a:ln>
         </p:spPr>
+        <p:txBody>
+          <a:bodyPr/>
+          <a:p/>
+        </p:txBody>
       </p:sp>
       <p:sp>
         <p:nvSpPr>
@@ -29244,6 +29616,10 @@
             </a:outerShdw>
           </a:effectLst>
         </p:spPr>
+        <p:txBody>
+          <a:bodyPr/>
+          <a:p/>
+        </p:txBody>
       </p:sp>
       <p:sp>
         <p:nvSpPr>
@@ -30067,7 +30443,7 @@
                 <a:ea typeface="Courier New" pitchFamily="34" charset="-122"/>
                 <a:cs typeface="Courier New" pitchFamily="34" charset="-120"/>
               </a:rPr>
-              <a:t>data</a:t>
+              <a:t>state</a:t>
             </a:r>
             <a:endParaRPr lang="en-US" sz="1200" dirty="0"/>
           </a:p>
@@ -31121,6 +31497,10 @@
             <a:prstDash val="solid"/>
           </a:ln>
         </p:spPr>
+        <p:txBody>
+          <a:bodyPr/>
+          <a:p/>
+        </p:txBody>
       </p:sp>
       <p:sp>
         <p:nvSpPr>
@@ -31504,6 +31884,10 @@
             <a:prstDash val="solid"/>
           </a:ln>
         </p:spPr>
+        <p:txBody>
+          <a:bodyPr/>
+          <a:p/>
+        </p:txBody>
       </p:sp>
       <p:sp>
         <p:nvSpPr>
@@ -31621,7 +32005,7 @@
                 <a:ea typeface="Arial" pitchFamily="34" charset="-122"/>
                 <a:cs typeface="Arial" pitchFamily="34" charset="-120"/>
               </a:rPr>
-              <a:t>Zyklen zwischen Libs. Ein Aufwärts-Import (api → data) meldet sich oft als „Circular dependency“</a:t>
+              <a:t>Zyklen zwischen Libs. Ein Aufwärts-Import (api → state) meldet sich oft als „Circular dependency“</a:t>
             </a:r>
             <a:endParaRPr lang="en-US" sz="1200" dirty="0"/>
           </a:p>
@@ -32119,6 +32503,10 @@
             <a:prstDash val="solid"/>
           </a:ln>
         </p:spPr>
+        <p:txBody>
+          <a:bodyPr/>
+          <a:p/>
+        </p:txBody>
       </p:sp>
       <p:sp>
         <p:nvSpPr>
@@ -32228,6 +32616,10 @@
             <a:prstDash val="solid"/>
           </a:ln>
         </p:spPr>
+        <p:txBody>
+          <a:bodyPr/>
+          <a:p/>
+        </p:txBody>
       </p:sp>
       <p:sp>
         <p:nvSpPr>
@@ -32333,6 +32725,10 @@
             <a:prstDash val="solid"/>
           </a:ln>
         </p:spPr>
+        <p:txBody>
+          <a:bodyPr/>
+          <a:p/>
+        </p:txBody>
       </p:sp>
       <p:sp>
         <p:nvSpPr>
@@ -32438,6 +32834,10 @@
             <a:prstDash val="solid"/>
           </a:ln>
         </p:spPr>
+        <p:txBody>
+          <a:bodyPr/>
+          <a:p/>
+        </p:txBody>
       </p:sp>
       <p:sp>
         <p:nvSpPr>
@@ -32472,7 +32872,7 @@
                 <a:ea typeface="Courier New" pitchFamily="34" charset="-122"/>
                 <a:cs typeface="Courier New" pitchFamily="34" charset="-120"/>
               </a:rPr>
-              <a:t>data · ui</a:t>
+              <a:t>state · ui</a:t>
             </a:r>
             <a:endParaRPr lang="en-US" sz="1050" dirty="0"/>
           </a:p>
@@ -32504,6 +32904,10 @@
             <a:prstDash val="solid"/>
           </a:ln>
         </p:spPr>
+        <p:txBody>
+          <a:bodyPr/>
+          <a:p/>
+        </p:txBody>
       </p:sp>
       <p:sp>
         <p:nvSpPr>
@@ -32570,6 +32974,10 @@
             <a:prstDash val="solid"/>
           </a:ln>
         </p:spPr>
+        <p:txBody>
+          <a:bodyPr/>
+          <a:p/>
+        </p:txBody>
       </p:sp>
       <p:sp>
         <p:nvSpPr>
@@ -32636,6 +33044,10 @@
             <a:prstDash val="solid"/>
           </a:ln>
         </p:spPr>
+        <p:txBody>
+          <a:bodyPr/>
+          <a:p/>
+        </p:txBody>
       </p:sp>
       <p:sp>
         <p:nvSpPr>
@@ -32745,6 +33157,10 @@
             <a:prstDash val="solid"/>
           </a:ln>
         </p:spPr>
+        <p:txBody>
+          <a:bodyPr/>
+          <a:p/>
+        </p:txBody>
       </p:sp>
       <p:sp>
         <p:nvSpPr>
@@ -32850,6 +33266,10 @@
             <a:prstDash val="solid"/>
           </a:ln>
         </p:spPr>
+        <p:txBody>
+          <a:bodyPr/>
+          <a:p/>
+        </p:txBody>
       </p:sp>
       <p:sp>
         <p:nvSpPr>
@@ -32955,6 +33375,10 @@
             <a:prstDash val="solid"/>
           </a:ln>
         </p:spPr>
+        <p:txBody>
+          <a:bodyPr/>
+          <a:p/>
+        </p:txBody>
       </p:sp>
       <p:sp>
         <p:nvSpPr>
@@ -32989,7 +33413,7 @@
                 <a:ea typeface="Courier New" pitchFamily="34" charset="-122"/>
                 <a:cs typeface="Courier New" pitchFamily="34" charset="-120"/>
               </a:rPr>
-              <a:t>data · ui</a:t>
+              <a:t>state · ui</a:t>
             </a:r>
             <a:endParaRPr lang="en-US" sz="1050" dirty="0"/>
           </a:p>
@@ -33021,6 +33445,10 @@
             <a:prstDash val="solid"/>
           </a:ln>
         </p:spPr>
+        <p:txBody>
+          <a:bodyPr/>
+          <a:p/>
+        </p:txBody>
       </p:sp>
       <p:sp>
         <p:nvSpPr>
@@ -33087,6 +33515,10 @@
             <a:prstDash val="solid"/>
           </a:ln>
         </p:spPr>
+        <p:txBody>
+          <a:bodyPr/>
+          <a:p/>
+        </p:txBody>
       </p:sp>
       <p:sp>
         <p:nvSpPr>
@@ -33153,6 +33585,10 @@
             <a:prstDash val="solid"/>
           </a:ln>
         </p:spPr>
+        <p:txBody>
+          <a:bodyPr/>
+          <a:p/>
+        </p:txBody>
       </p:sp>
       <p:sp>
         <p:nvSpPr>
@@ -33219,6 +33655,10 @@
             <a:prstDash val="solid"/>
           </a:ln>
         </p:spPr>
+        <p:txBody>
+          <a:bodyPr/>
+          <a:p/>
+        </p:txBody>
       </p:sp>
       <p:sp>
         <p:nvSpPr>
@@ -33324,6 +33764,10 @@
             <a:prstDash val="solid"/>
           </a:ln>
         </p:spPr>
+        <p:txBody>
+          <a:bodyPr/>
+          <a:p/>
+        </p:txBody>
       </p:sp>
       <p:sp>
         <p:nvSpPr>
@@ -33429,6 +33873,10 @@
             <a:prstDash val="solid"/>
           </a:ln>
         </p:spPr>
+        <p:txBody>
+          <a:bodyPr/>
+          <a:p/>
+        </p:txBody>
       </p:sp>
       <p:sp>
         <p:nvSpPr>
@@ -33534,6 +33982,10 @@
             <a:prstDash val="solid"/>
           </a:ln>
         </p:spPr>
+        <p:txBody>
+          <a:bodyPr/>
+          <a:p/>
+        </p:txBody>
       </p:sp>
       <p:sp>
         <p:nvSpPr>
@@ -33568,7 +34020,7 @@
                 <a:ea typeface="Courier New" pitchFamily="34" charset="-122"/>
                 <a:cs typeface="Courier New" pitchFamily="34" charset="-120"/>
               </a:rPr>
-              <a:t>auth/data</a:t>
+              <a:t>auth/state</a:t>
             </a:r>
             <a:endParaRPr lang="en-US" sz="1050" dirty="0"/>
           </a:p>
@@ -33600,6 +34052,10 @@
             <a:prstDash val="solid"/>
           </a:ln>
         </p:spPr>
+        <p:txBody>
+          <a:bodyPr/>
+          <a:p/>
+        </p:txBody>
       </p:sp>
       <p:sp>
         <p:nvSpPr>
@@ -33748,6 +34204,10 @@
             <a:prstDash val="dash"/>
           </a:ln>
         </p:spPr>
+        <p:txBody>
+          <a:bodyPr/>
+          <a:p/>
+        </p:txBody>
       </p:sp>
       <p:sp>
         <p:nvSpPr>
@@ -33857,6 +34317,10 @@
             <a:prstDash val="solid"/>
           </a:ln>
         </p:spPr>
+        <p:txBody>
+          <a:bodyPr/>
+          <a:p/>
+        </p:txBody>
       </p:sp>
       <p:sp>
         <p:nvSpPr>
@@ -33923,6 +34387,10 @@
             <a:prstDash val="solid"/>
           </a:ln>
         </p:spPr>
+        <p:txBody>
+          <a:bodyPr/>
+          <a:p/>
+        </p:txBody>
       </p:sp>
       <p:sp>
         <p:nvSpPr>
@@ -33989,6 +34457,10 @@
             <a:prstDash val="solid"/>
           </a:ln>
         </p:spPr>
+        <p:txBody>
+          <a:bodyPr/>
+          <a:p/>
+        </p:txBody>
       </p:sp>
       <p:sp>
         <p:nvSpPr>
@@ -34055,6 +34527,10 @@
             <a:prstDash val="solid"/>
           </a:ln>
         </p:spPr>
+        <p:txBody>
+          <a:bodyPr/>
+          <a:p/>
+        </p:txBody>
       </p:sp>
       <p:sp>
         <p:nvSpPr>
@@ -34118,6 +34594,10 @@
             <a:tailEnd type="triangle"/>
           </a:ln>
         </p:spPr>
+        <p:txBody>
+          <a:bodyPr/>
+          <a:p/>
+        </p:txBody>
       </p:sp>
       <p:sp>
         <p:nvSpPr>
@@ -34183,6 +34663,10 @@
             <a:tailEnd type="triangle"/>
           </a:ln>
         </p:spPr>
+        <p:txBody>
+          <a:bodyPr/>
+          <a:p/>
+        </p:txBody>
       </p:sp>
       <p:sp>
         <p:nvSpPr>
@@ -34248,6 +34732,10 @@
             <a:tailEnd type="triangle"/>
           </a:ln>
         </p:spPr>
+        <p:txBody>
+          <a:bodyPr/>
+          <a:p/>
+        </p:txBody>
       </p:sp>
       <p:sp>
         <p:nvSpPr>
@@ -34352,6 +34840,10 @@
             <a:tailEnd type="triangle"/>
           </a:ln>
         </p:spPr>
+        <p:txBody>
+          <a:bodyPr/>
+          <a:p/>
+        </p:txBody>
       </p:sp>
       <p:sp>
         <p:nvSpPr>
@@ -34417,6 +34909,10 @@
             <a:tailEnd type="triangle"/>
           </a:ln>
         </p:spPr>
+        <p:txBody>
+          <a:bodyPr/>
+          <a:p/>
+        </p:txBody>
       </p:sp>
       <p:sp>
         <p:nvSpPr>
@@ -34485,6 +34981,10 @@
             <a:prstDash val="solid"/>
           </a:ln>
         </p:spPr>
+        <p:txBody>
+          <a:bodyPr/>
+          <a:p/>
+        </p:txBody>
       </p:sp>
       <p:sp>
         <p:nvSpPr>
@@ -34602,7 +35102,7 @@
                 <a:ea typeface="Courier New" pitchFamily="34" charset="-122"/>
                 <a:cs typeface="Courier New" pitchFamily="34" charset="-120"/>
               </a:rPr>
-              <a:t>checkin/data</a:t>
+              <a:t>checkin/state</a:t>
             </a:r>
             <a:pPr indent="0" marL="0">
               <a:lnSpc>
@@ -34919,6 +35419,10 @@
             <a:prstDash val="solid"/>
           </a:ln>
         </p:spPr>
+        <p:txBody>
+          <a:bodyPr/>
+          <a:p/>
+        </p:txBody>
       </p:sp>
       <p:sp>
         <p:nvSpPr>
@@ -35036,7 +35540,7 @@
                 <a:ea typeface="Courier New" pitchFamily="34" charset="-122"/>
                 <a:cs typeface="Courier New" pitchFamily="34" charset="-120"/>
               </a:rPr>
-              <a:t>checkin/data</a:t>
+              <a:t>checkin/state</a:t>
             </a:r>
             <a:pPr indent="0" marL="0">
               <a:lnSpc>
@@ -35070,7 +35574,7 @@
                 <a:ea typeface="Courier New" pitchFamily="34" charset="-122"/>
                 <a:cs typeface="Courier New" pitchFamily="34" charset="-120"/>
               </a:rPr>
-              <a:t>booking/data</a:t>
+              <a:t>booking/state</a:t>
             </a:r>
             <a:pPr indent="0" marL="0">
               <a:lnSpc>
@@ -35705,7 +36209,7 @@
                 <a:ea typeface="Arial" pitchFamily="34" charset="-122"/>
                 <a:cs typeface="Arial" pitchFamily="34" charset="-120"/>
               </a:rPr>
-              <a:t>; api, data und ui sind eigene Libs, damit die Layer-Matrix auch im Feat gilt.</a:t>
+              <a:t>; api, state und ui sind eigene Libs, damit die Layer-Matrix auch im Feat gilt.</a:t>
             </a:r>
             <a:endParaRPr lang="en-US" sz="1400" dirty="0"/>
           </a:p>
@@ -35737,6 +36241,10 @@
             <a:prstDash val="dash"/>
           </a:ln>
         </p:spPr>
+        <p:txBody>
+          <a:bodyPr/>
+          <a:p/>
+        </p:txBody>
       </p:sp>
       <p:sp>
         <p:nvSpPr>
@@ -35846,6 +36354,10 @@
             <a:prstDash val="solid"/>
           </a:ln>
         </p:spPr>
+        <p:txBody>
+          <a:bodyPr/>
+          <a:p/>
+        </p:txBody>
       </p:sp>
       <p:sp>
         <p:nvSpPr>
@@ -35955,6 +36467,10 @@
             <a:prstDash val="solid"/>
           </a:ln>
         </p:spPr>
+        <p:txBody>
+          <a:bodyPr/>
+          <a:p/>
+        </p:txBody>
       </p:sp>
       <p:sp>
         <p:nvSpPr>
@@ -36060,6 +36576,10 @@
             <a:prstDash val="solid"/>
           </a:ln>
         </p:spPr>
+        <p:txBody>
+          <a:bodyPr/>
+          <a:p/>
+        </p:txBody>
       </p:sp>
       <p:sp>
         <p:nvSpPr>
@@ -36165,6 +36685,10 @@
             <a:prstDash val="solid"/>
           </a:ln>
         </p:spPr>
+        <p:txBody>
+          <a:bodyPr/>
+          <a:p/>
+        </p:txBody>
       </p:sp>
       <p:sp>
         <p:nvSpPr>
@@ -36199,7 +36723,7 @@
                 <a:ea typeface="Courier New" pitchFamily="34" charset="-122"/>
                 <a:cs typeface="Courier New" pitchFamily="34" charset="-120"/>
               </a:rPr>
-              <a:t>data</a:t>
+              <a:t>state</a:t>
             </a:r>
             <a:endParaRPr lang="en-US" sz="1150" dirty="0"/>
           </a:p>
@@ -36270,6 +36794,10 @@
             <a:prstDash val="solid"/>
           </a:ln>
         </p:spPr>
+        <p:txBody>
+          <a:bodyPr/>
+          <a:p/>
+        </p:txBody>
       </p:sp>
       <p:sp>
         <p:nvSpPr>
@@ -36379,6 +36907,10 @@
             <a:prstDash val="solid"/>
           </a:ln>
         </p:spPr>
+        <p:txBody>
+          <a:bodyPr/>
+          <a:p/>
+        </p:txBody>
       </p:sp>
       <p:sp>
         <p:nvSpPr>
@@ -36484,6 +37016,10 @@
             <a:prstDash val="solid"/>
           </a:ln>
         </p:spPr>
+        <p:txBody>
+          <a:bodyPr/>
+          <a:p/>
+        </p:txBody>
       </p:sp>
       <p:sp>
         <p:nvSpPr>
@@ -36518,7 +37054,7 @@
                 <a:ea typeface="Courier New" pitchFamily="34" charset="-122"/>
                 <a:cs typeface="Courier New" pitchFamily="34" charset="-120"/>
               </a:rPr>
-              <a:t>checkin/data</a:t>
+              <a:t>checkin/state</a:t>
             </a:r>
             <a:endParaRPr lang="en-US" sz="1200" dirty="0"/>
           </a:p>
@@ -36629,6 +37165,10 @@
             <a:tailEnd type="triangle"/>
           </a:ln>
         </p:spPr>
+        <p:txBody>
+          <a:bodyPr/>
+          <a:p/>
+        </p:txBody>
       </p:sp>
       <p:sp>
         <p:nvSpPr>
@@ -36694,6 +37234,10 @@
             <a:tailEnd type="triangle"/>
           </a:ln>
         </p:spPr>
+        <p:txBody>
+          <a:bodyPr/>
+          <a:p/>
+        </p:txBody>
       </p:sp>
       <p:sp>
         <p:nvSpPr>
@@ -36759,6 +37303,10 @@
             <a:tailEnd type="triangle"/>
           </a:ln>
         </p:spPr>
+        <p:txBody>
+          <a:bodyPr/>
+          <a:p/>
+        </p:txBody>
       </p:sp>
       <p:sp>
         <p:nvSpPr>
@@ -36894,6 +37442,10 @@
             <a:prstDash val="solid"/>
           </a:ln>
         </p:spPr>
+        <p:txBody>
+          <a:bodyPr/>
+          <a:p/>
+        </p:txBody>
       </p:sp>
       <p:sp>
         <p:nvSpPr>
@@ -37171,6 +37723,10 @@
             <a:prstDash val="solid"/>
           </a:ln>
         </p:spPr>
+        <p:txBody>
+          <a:bodyPr/>
+          <a:p/>
+        </p:txBody>
       </p:sp>
       <p:sp>
         <p:nvSpPr>
@@ -37322,7 +37878,7 @@
                 <a:ea typeface="Courier New" pitchFamily="34" charset="-122"/>
                 <a:cs typeface="Courier New" pitchFamily="34" charset="-120"/>
               </a:rPr>
-              <a:t>…/data</a:t>
+              <a:t>…/state</a:t>
             </a:r>
             <a:pPr indent="0" marL="0">
               <a:lnSpc>
@@ -37473,7 +38029,7 @@
                 <a:ea typeface="Courier New" pitchFamily="34" charset="-122"/>
                 <a:cs typeface="Courier New" pitchFamily="34" charset="-120"/>
               </a:rPr>
-              <a:t>…/data</a:t>
+              <a:t>…/state</a:t>
             </a:r>
             <a:pPr indent="0" marL="0">
               <a:lnSpc>
@@ -37573,7 +38129,7 @@
                 <a:ea typeface="Courier New" pitchFamily="34" charset="-122"/>
                 <a:cs typeface="Courier New" pitchFamily="34" charset="-120"/>
               </a:rPr>
-              <a:t>booking/data</a:t>
+              <a:t>booking/state</a:t>
             </a:r>
             <a:pPr indent="0" marL="0">
               <a:lnSpc>
@@ -37607,7 +38163,7 @@
                 <a:ea typeface="Courier New" pitchFamily="34" charset="-122"/>
                 <a:cs typeface="Courier New" pitchFamily="34" charset="-120"/>
               </a:rPr>
-              <a:t>feat-check-booking/data</a:t>
+              <a:t>feat-check-booking/state</a:t>
             </a:r>
             <a:pPr indent="0" marL="0">
               <a:lnSpc>
@@ -37879,6 +38435,10 @@
             </a:outerShdw>
           </a:effectLst>
         </p:spPr>
+        <p:txBody>
+          <a:bodyPr/>
+          <a:p/>
+        </p:txBody>
       </p:sp>
       <p:sp>
         <p:nvSpPr>
@@ -38313,7 +38873,7 @@
                 <a:ea typeface="Courier New" pitchFamily="34" charset="-122"/>
                 <a:cs typeface="Courier New" pitchFamily="34" charset="-120"/>
               </a:rPr>
-              <a:t>booking/data</a:t>
+              <a:t>booking/state</a:t>
             </a:r>
             <a:pPr indent="0" marL="0">
               <a:lnSpc>
@@ -38330,7 +38890,7 @@
                 <a:ea typeface="Arial" pitchFamily="34" charset="-122"/>
                 <a:cs typeface="Arial" pitchFamily="34" charset="-120"/>
               </a:rPr>
-              <a:t>: Zyklus, weil der Spec in data testing importiert</a:t>
+              <a:t>: Zyklus, weil der Spec in state testing importiert</a:t>
             </a:r>
             <a:endParaRPr lang="en-US" sz="1400" dirty="0"/>
           </a:p>
@@ -38518,6 +39078,10 @@
             <a:prstDash val="solid"/>
           </a:ln>
         </p:spPr>
+        <p:txBody>
+          <a:bodyPr/>
+          <a:p/>
+        </p:txBody>
       </p:sp>
       <p:sp>
         <p:nvSpPr>
@@ -38692,6 +39256,10 @@
             <a:prstDash val="solid"/>
           </a:ln>
         </p:spPr>
+        <p:txBody>
+          <a:bodyPr/>
+          <a:p/>
+        </p:txBody>
       </p:sp>
       <p:sp>
         <p:nvSpPr>
@@ -38880,6 +39448,10 @@
             <a:prstDash val="solid"/>
           </a:ln>
         </p:spPr>
+        <p:txBody>
+          <a:bodyPr/>
+          <a:p/>
+        </p:txBody>
       </p:sp>
       <p:sp>
         <p:nvSpPr>
@@ -39040,6 +39612,10 @@
             <a:prstDash val="solid"/>
           </a:ln>
         </p:spPr>
+        <p:txBody>
+          <a:bodyPr/>
+          <a:p/>
+        </p:txBody>
       </p:sp>
       <p:sp>
         <p:nvSpPr>
@@ -39214,6 +39790,10 @@
             <a:prstDash val="solid"/>
           </a:ln>
         </p:spPr>
+        <p:txBody>
+          <a:bodyPr/>
+          <a:p/>
+        </p:txBody>
       </p:sp>
       <p:sp>
         <p:nvSpPr>
@@ -39402,6 +39982,10 @@
             <a:prstDash val="solid"/>
           </a:ln>
         </p:spPr>
+        <p:txBody>
+          <a:bodyPr/>
+          <a:p/>
+        </p:txBody>
       </p:sp>
       <p:sp>
         <p:nvSpPr>
@@ -39576,6 +40160,10 @@
             <a:prstDash val="solid"/>
           </a:ln>
         </p:spPr>
+        <p:txBody>
+          <a:bodyPr/>
+          <a:p/>
+        </p:txBody>
       </p:sp>
       <p:sp>
         <p:nvSpPr>
@@ -39750,6 +40338,10 @@
             <a:prstDash val="solid"/>
           </a:ln>
         </p:spPr>
+        <p:txBody>
+          <a:bodyPr/>
+          <a:p/>
+        </p:txBody>
       </p:sp>
       <p:sp>
         <p:nvSpPr>

</xml_diff>

<commit_message>
docs: matrix zeigt testing in specs für jeden layer (✓ spec), types ausgenommen
Co-Authored-By: Claude Opus 5.5 (1M context) <noreply@anthropic.com>
</commit_message>
<xml_diff>
--- a/docs/architektur.pptx
+++ b/docs/architektur.pptx
@@ -123,14 +123,14 @@
   <p:extLst>
     <p:ext uri="{521415D9-36F7-43E2-AB2F-B90AF26B5E84}">
       <p14:sectionLst xmlns:p14="http://schemas.microsoft.com/office/powerpoint/2010/main">
-        <p14:section name="Einstieg" id="{f603e1cb-ff4e-0948-8506-2a0998b58dc0}">
+        <p14:section name="Einstieg" id="{b5f20878-30d6-784f-d28e-50b8ab97500d}">
           <p14:sldIdLst>
             <p14:sldId id="256"/>
             <p14:sldId id="257"/>
             <p14:sldId id="258"/>
           </p14:sldIdLst>
         </p14:section>
-        <p14:section name="Regeln" id="{bbfa7524-629d-1d72-c8d7-87ac02235720}">
+        <p14:section name="Regeln" id="{77982d8f-ce5f-80be-4884-b3383b937bc0}">
           <p14:sldIdLst>
             <p14:sldId id="259"/>
             <p14:sldId id="260"/>
@@ -144,13 +144,13 @@
             <p14:sldId id="268"/>
           </p14:sldIdLst>
         </p14:section>
-        <p14:section name="Beispiele" id="{dd30f4d8-f924-9564-39db-ecbdc916a8c1}">
+        <p14:section name="Beispiele" id="{933d1011-4433-f85e-3e0c-271e7ba27557}">
           <p14:sldIdLst>
             <p14:sldId id="269"/>
             <p14:sldId id="270"/>
           </p14:sldIdLst>
         </p14:section>
-        <p14:section name="Werkzeuge" id="{5c0514d5-f23a-cfca-c9a3-650aa22679e1}">
+        <p14:section name="Werkzeuge" id="{5c918b43-0eea-de8b-e574-4b1ee9dfa432}">
           <p14:sldIdLst>
             <p14:sldId id="271"/>
             <p14:sldId id="272"/>
@@ -24237,14 +24237,14 @@
                         <a:buNone/>
                       </a:pPr>
                       <a:r>
-                        <a:rPr lang="en-US" sz="1100" dirty="0">
+                        <a:rPr lang="en-US" sz="900" b="1" dirty="0">
                           <a:solidFill>
-                            <a:schemeClr val="tx2"/>
+                            <a:schemeClr val="accent1"/>
                           </a:solidFill>
                         </a:rPr>
-                        <a:t>·</a:t>
+                        <a:t>✓ Spec</a:t>
                       </a:r>
-                      <a:endParaRPr lang="en-US" sz="1100" dirty="0"/>
+                      <a:endParaRPr lang="en-US" sz="900" dirty="0"/>
                     </a:p>
                   </a:txBody>
                   <a:tcPr marL="63500" marR="63500" marT="38100" marB="38100" anchor="ctr">
@@ -24285,7 +24285,7 @@
                       <a:tailEnd type="none" w="med" len="med"/>
                     </a:lnB>
                     <a:solidFill>
-                      <a:schemeClr val="bg2"/>
+                      <a:schemeClr val="bg1"/>
                     </a:solidFill>
                   </a:tcPr>
                 </a:tc>
@@ -24731,14 +24731,14 @@
                         <a:buNone/>
                       </a:pPr>
                       <a:r>
-                        <a:rPr lang="en-US" sz="1100" dirty="0">
+                        <a:rPr lang="en-US" sz="900" b="1" dirty="0">
                           <a:solidFill>
-                            <a:schemeClr val="tx2"/>
+                            <a:schemeClr val="accent1"/>
                           </a:solidFill>
                         </a:rPr>
-                        <a:t>·</a:t>
+                        <a:t>✓ Spec</a:t>
                       </a:r>
-                      <a:endParaRPr lang="en-US" sz="1100" dirty="0"/>
+                      <a:endParaRPr lang="en-US" sz="900" dirty="0"/>
                     </a:p>
                   </a:txBody>
                   <a:tcPr marL="63500" marR="63500" marT="38100" marB="38100" anchor="ctr">
@@ -24779,7 +24779,7 @@
                       <a:tailEnd type="none" w="med" len="med"/>
                     </a:lnB>
                     <a:solidFill>
-                      <a:schemeClr val="bg2"/>
+                      <a:schemeClr val="bg1"/>
                     </a:solidFill>
                   </a:tcPr>
                 </a:tc>
@@ -25225,14 +25225,14 @@
                         <a:buNone/>
                       </a:pPr>
                       <a:r>
-                        <a:rPr lang="en-US" sz="1100" dirty="0">
+                        <a:rPr lang="en-US" sz="900" b="1" dirty="0">
                           <a:solidFill>
-                            <a:schemeClr val="tx2"/>
+                            <a:schemeClr val="accent1"/>
                           </a:solidFill>
                         </a:rPr>
-                        <a:t>·</a:t>
+                        <a:t>✓ Spec</a:t>
                       </a:r>
-                      <a:endParaRPr lang="en-US" sz="1100" dirty="0"/>
+                      <a:endParaRPr lang="en-US" sz="900" dirty="0"/>
                     </a:p>
                   </a:txBody>
                   <a:tcPr marL="63500" marR="63500" marT="38100" marB="38100" anchor="ctr">
@@ -25273,7 +25273,7 @@
                       <a:tailEnd type="none" w="med" len="med"/>
                     </a:lnB>
                     <a:solidFill>
-                      <a:schemeClr val="bg2"/>
+                      <a:schemeClr val="bg1"/>
                     </a:solidFill>
                   </a:tcPr>
                 </a:tc>
@@ -25719,14 +25719,14 @@
                         <a:buNone/>
                       </a:pPr>
                       <a:r>
-                        <a:rPr lang="en-US" sz="1100" dirty="0">
+                        <a:rPr lang="en-US" sz="900" b="1" dirty="0">
                           <a:solidFill>
-                            <a:schemeClr val="tx2"/>
+                            <a:schemeClr val="accent1"/>
                           </a:solidFill>
                         </a:rPr>
-                        <a:t>·</a:t>
+                        <a:t>✓ Spec</a:t>
                       </a:r>
-                      <a:endParaRPr lang="en-US" sz="1100" dirty="0"/>
+                      <a:endParaRPr lang="en-US" sz="900" dirty="0"/>
                     </a:p>
                   </a:txBody>
                   <a:tcPr marL="63500" marR="63500" marT="38100" marB="38100" anchor="ctr">
@@ -25767,7 +25767,7 @@
                       <a:tailEnd type="none" w="med" len="med"/>
                     </a:lnB>
                     <a:solidFill>
-                      <a:schemeClr val="bg2"/>
+                      <a:schemeClr val="bg1"/>
                     </a:solidFill>
                   </a:tcPr>
                 </a:tc>
@@ -26213,14 +26213,14 @@
                         <a:buNone/>
                       </a:pPr>
                       <a:r>
-                        <a:rPr lang="en-US" sz="1100" dirty="0">
+                        <a:rPr lang="en-US" sz="900" b="1" dirty="0">
                           <a:solidFill>
-                            <a:schemeClr val="tx2"/>
+                            <a:schemeClr val="accent1"/>
                           </a:solidFill>
                         </a:rPr>
-                        <a:t>·</a:t>
+                        <a:t>✓ Spec</a:t>
                       </a:r>
-                      <a:endParaRPr lang="en-US" sz="1100" dirty="0"/>
+                      <a:endParaRPr lang="en-US" sz="900" dirty="0"/>
                     </a:p>
                   </a:txBody>
                   <a:tcPr marL="63500" marR="63500" marT="38100" marB="38100" anchor="ctr">
@@ -26261,7 +26261,7 @@
                       <a:tailEnd type="none" w="med" len="med"/>
                     </a:lnB>
                     <a:solidFill>
-                      <a:schemeClr val="bg2"/>
+                      <a:schemeClr val="bg1"/>
                     </a:solidFill>
                   </a:tcPr>
                 </a:tc>
@@ -27124,7 +27124,7 @@
                 <a:ea typeface="Courier New" pitchFamily="34" charset="-122"/>
                 <a:cs typeface="Courier New" pitchFamily="34" charset="-120"/>
               </a:rPr>
-              <a:t>Specs</a:t>
+              <a:t>✓ Spec</a:t>
             </a:r>
             <a:endParaRPr lang="en-US" sz="1200" dirty="0"/>
           </a:p>
@@ -27160,7 +27160,7 @@
                   <a:schemeClr val="tx2"/>
                 </a:solidFill>
               </a:rPr>
-              <a:t>jede Zeile darf zusätzlich testing (eigener Slice + shared).</a:t>
+              <a:t>nur in *.spec.ts, eigener Slice + shared. types nicht: testing baut auf types auf (Zyklus).</a:t>
             </a:r>
             <a:endParaRPr lang="en-US" sz="1100" dirty="0"/>
           </a:p>

</xml_diff>